<commit_message>
Docs: refine P1 presentation stack and expand README documentation
- Add HTML5, CSS3, JS, and AJAX to Slide 4 and README stack section
- Include A1-A12 requirement ownership matrix in README.md

Co-Authored-By: Popa-Ion-Andrei <171177559+Popa-Ion-Andrei@users.noreply.github.com>
</commit_message>
<xml_diff>
--- a/Presentations/P1/NexusGear_P1_Team_Setup_and_Planning.pptx
+++ b/Presentations/P1/NexusGear_P1_Team_Setup_and_Planning.pptx
@@ -15077,24 +15077,24 @@
         <p:spPr>
           <a:xfrm>
             <a:off x="1554480" y="1847160"/>
-            <a:ext cx="3017160" cy="255600"/>
-          </a:xfrm>
-          <a:prstGeom prst="rect">
-            <a:avLst/>
-          </a:prstGeom>
-          <a:noFill/>
-          <a:ln w="0">
-            <a:noFill/>
-          </a:ln>
-        </p:spPr>
-        <p:style>
-          <a:lnRef idx="0"/>
-          <a:fillRef idx="0"/>
-          <a:effectRef idx="0"/>
-          <a:fontRef idx="minor"/>
-        </p:style>
-        <p:txBody>
-          <a:bodyPr lIns="0" tIns="0" rIns="0" bIns="0" anchor="ctr">
+            <a:ext cx="3017160" cy="393192"/>
+          </a:xfrm>
+          <a:prstGeom prst="rect">
+            <a:avLst/>
+          </a:prstGeom>
+          <a:noFill/>
+          <a:ln w="0">
+            <a:noFill/>
+          </a:ln>
+        </p:spPr>
+        <p:style>
+          <a:lnRef idx="0"/>
+          <a:fillRef idx="0"/>
+          <a:effectRef idx="0"/>
+          <a:fontRef idx="minor"/>
+        </p:style>
+        <p:txBody>
+          <a:bodyPr lIns="0" tIns="0" rIns="0" bIns="0" anchor="ctr" wrap="square">
             <a:normAutofit/>
           </a:bodyPr>
           <a:p>
@@ -15102,12 +15102,18 @@
               <a:lnSpc>
                 <a:spcPct val="100000"/>
               </a:lnSpc>
+              <a:spcBef>
+                <a:spcPts val="0"/>
+              </a:spcBef>
+              <a:spcAft>
+                <a:spcPts val="0"/>
+              </a:spcAft>
               <a:tabLst>
                 <a:tab pos="0" algn="l"/>
               </a:tabLst>
             </a:pPr>
             <a:r>
-              <a:rPr lang="en-US" sz="1400" b="1" u="none" strike="noStrike">
+              <a:rPr lang="en-US" sz="1220" b="1" u="none" strike="noStrike">
                 <a:solidFill>
                   <a:srgbClr val="F4F7FC"/>
                 </a:solidFill>
@@ -15116,7 +15122,8 @@
                 <a:latin typeface="Aptos"/>
                 <a:ea typeface="Aptos"/>
               </a:rPr>
-              <a:t>Bootstrap 5 + Bootstrap Icons</a:t>
+              <a:t>HTML5 · CSS3 · JavaScript · AJAX
+Bootstrap 5 + Bootstrap Icons</a:t>
             </a:r>
             <a:endParaRPr lang="en-US" sz="1400" b="0" u="none" strike="noStrike">
               <a:solidFill>
@@ -15168,7 +15175,7 @@
               </a:tabLst>
             </a:pPr>
             <a:r>
-              <a:rPr lang="en-US" sz="1020" b="0" u="none" strike="noStrike">
+              <a:rPr lang="en-US" sz="1019" b="0" u="none" strike="noStrike">
                 <a:solidFill>
                   <a:srgbClr val="AAB6C9"/>
                 </a:solidFill>
@@ -15177,7 +15184,7 @@
                 <a:latin typeface="Aptos"/>
                 <a:ea typeface="Aptos"/>
               </a:rPr>
-              <a:t>Mobile-first responsive layout with accessible, reusable components and no separate client-framework build complexity.</a:t>
+              <a:t>Mobile-first responsive UI with reusable Bootstrap components; JavaScript and AJAX support interactive pages and asynchronous updates.</a:t>
             </a:r>
             <a:endParaRPr lang="en-US" sz="1020" b="0" u="none" strike="noStrike">
               <a:solidFill>

</xml_diff>